<commit_message>
FSD deck (docs/Restaurant_OS_FSD.pptx) with DFD Level 0 and Level 1, and its generator
Co-Authored-By: Claude Opus 5.5 <noreply@anthropic.com>
</commit_message>
<xml_diff>
--- a/docs/Restaurant_OS_FSD.pptx
+++ b/docs/Restaurant_OS_FSD.pptx
@@ -6502,6 +6502,40 @@
                 <a:latin typeface="Calibri"/>
               </a:rPr>
               <a:t> Receipt: company logo, 80 / 58 mm or A4, auto-print option</a:t>
+            </a:r>
+          </a:p>
+          <a:p>
+            <a:pPr>
+              <a:spcAft>
+                <a:spcPts val="900"/>
+              </a:spcAft>
+            </a:pPr>
+            <a:r>
+              <a:rPr sz="1500" b="1" i="0">
+                <a:solidFill>
+                  <a:srgbClr val="0D9488"/>
+                </a:solidFill>
+                <a:latin typeface="Calibri"/>
+              </a:rPr>
+              <a:t>•  </a:t>
+            </a:r>
+            <a:r>
+              <a:rPr sz="1500" b="1" i="0">
+                <a:solidFill>
+                  <a:srgbClr val="1E293B"/>
+                </a:solidFill>
+                <a:latin typeface="Calibri"/>
+              </a:rPr>
+              <a:t>FR-2.9 </a:t>
+            </a:r>
+            <a:r>
+              <a:rPr sz="1500" b="0" i="0">
+                <a:solidFill>
+                  <a:srgbClr val="1E293B"/>
+                </a:solidFill>
+                <a:latin typeface="Calibri"/>
+              </a:rPr>
+              <a:t> Customer-facing display (/ros/display): live cart with dish photos and offers, amount to pay / change, thank-you with FBR QR; menu &amp; offers slideshow between customers</a:t>
             </a:r>
           </a:p>
         </p:txBody>
@@ -14990,7 +15024,7 @@
                 </a:solidFill>
                 <a:latin typeface="Calibri"/>
               </a:rPr>
-              <a:t> receipt printer — POS terminal → Printer; KDS — open /ros/kds on the kitchen screen and pick its station; kiosk — /ros/kiosk in full-screen; riders — /ros/rider on their phones</a:t>
+              <a:t> receipt printer — POS terminal → Printer; customer display — terminal → Customer display (2nd monitor); KDS — /ros/kds on the kitchen screen, pick its station; kiosk — /ros/kiosk full-screen; riders — /ros/rider on their phones</a:t>
             </a:r>
           </a:p>
           <a:p>
@@ -15885,7 +15919,7 @@
         <p:spPr>
           <a:xfrm>
             <a:off x="502920" y="1463040"/>
-            <a:ext cx="1161288" cy="1143000"/>
+            <a:ext cx="1161288" cy="640080"/>
           </a:xfrm>
           <a:prstGeom prst="homePlate">
             <a:avLst/>
@@ -15913,8 +15947,8 @@
         </p:nvSpPr>
         <p:spPr>
           <a:xfrm>
-            <a:off x="667512" y="1572768"/>
-            <a:ext cx="886968" cy="365760"/>
+            <a:off x="640080" y="1572768"/>
+            <a:ext cx="886968" cy="411480"/>
           </a:xfrm>
           <a:prstGeom prst="rect">
             <a:avLst/>
@@ -15948,8 +15982,8 @@
         </p:nvSpPr>
         <p:spPr>
           <a:xfrm>
-            <a:off x="667512" y="1938528"/>
-            <a:ext cx="886968" cy="640080"/>
+            <a:off x="457200" y="2148840"/>
+            <a:ext cx="1252728" cy="502920"/>
           </a:xfrm>
           <a:prstGeom prst="rect">
             <a:avLst/>
@@ -15966,7 +16000,7 @@
             <a:r>
               <a:rPr sz="1100" b="1" i="0">
                 <a:solidFill>
-                  <a:srgbClr val="FFFFFF"/>
+                  <a:srgbClr val="0B5E57"/>
                 </a:solidFill>
                 <a:latin typeface="Calibri"/>
               </a:rPr>
@@ -15978,7 +16012,7 @@
             <a:r>
               <a:rPr sz="1100" b="1" i="0">
                 <a:solidFill>
-                  <a:srgbClr val="FFFFFF"/>
+                  <a:srgbClr val="0B5E57"/>
                 </a:solidFill>
                 <a:latin typeface="Calibri"/>
               </a:rPr>
@@ -15996,7 +16030,7 @@
         <p:spPr>
           <a:xfrm>
             <a:off x="1773936" y="1463040"/>
-            <a:ext cx="1161288" cy="1143000"/>
+            <a:ext cx="1161288" cy="640080"/>
           </a:xfrm>
           <a:prstGeom prst="chevron">
             <a:avLst/>
@@ -16024,8 +16058,8 @@
         </p:nvSpPr>
         <p:spPr>
           <a:xfrm>
-            <a:off x="1938528" y="1572768"/>
-            <a:ext cx="886968" cy="365760"/>
+            <a:off x="1911096" y="1572768"/>
+            <a:ext cx="886968" cy="411480"/>
           </a:xfrm>
           <a:prstGeom prst="rect">
             <a:avLst/>
@@ -16059,8 +16093,8 @@
         </p:nvSpPr>
         <p:spPr>
           <a:xfrm>
-            <a:off x="1938528" y="1938528"/>
-            <a:ext cx="886968" cy="640080"/>
+            <a:off x="1728216" y="2148840"/>
+            <a:ext cx="1252728" cy="502920"/>
           </a:xfrm>
           <a:prstGeom prst="rect">
             <a:avLst/>
@@ -16077,7 +16111,7 @@
             <a:r>
               <a:rPr sz="1100" b="1" i="0">
                 <a:solidFill>
-                  <a:srgbClr val="FFFFFF"/>
+                  <a:srgbClr val="0B5E57"/>
                 </a:solidFill>
                 <a:latin typeface="Calibri"/>
               </a:rPr>
@@ -16089,7 +16123,7 @@
             <a:r>
               <a:rPr sz="1100" b="1" i="0">
                 <a:solidFill>
-                  <a:srgbClr val="FFFFFF"/>
+                  <a:srgbClr val="0B5E57"/>
                 </a:solidFill>
                 <a:latin typeface="Calibri"/>
               </a:rPr>
@@ -16107,7 +16141,7 @@
         <p:spPr>
           <a:xfrm>
             <a:off x="3044952" y="1463040"/>
-            <a:ext cx="1161288" cy="1143000"/>
+            <a:ext cx="1161288" cy="640080"/>
           </a:xfrm>
           <a:prstGeom prst="chevron">
             <a:avLst/>
@@ -16135,8 +16169,8 @@
         </p:nvSpPr>
         <p:spPr>
           <a:xfrm>
-            <a:off x="3209544" y="1572768"/>
-            <a:ext cx="886968" cy="365760"/>
+            <a:off x="3182112" y="1572768"/>
+            <a:ext cx="886968" cy="411480"/>
           </a:xfrm>
           <a:prstGeom prst="rect">
             <a:avLst/>
@@ -16170,8 +16204,8 @@
         </p:nvSpPr>
         <p:spPr>
           <a:xfrm>
-            <a:off x="3209544" y="1938528"/>
-            <a:ext cx="886968" cy="640080"/>
+            <a:off x="2999232" y="2148840"/>
+            <a:ext cx="1252728" cy="502920"/>
           </a:xfrm>
           <a:prstGeom prst="rect">
             <a:avLst/>
@@ -16188,7 +16222,7 @@
             <a:r>
               <a:rPr sz="1100" b="1" i="0">
                 <a:solidFill>
-                  <a:srgbClr val="FFFFFF"/>
+                  <a:srgbClr val="0B5E57"/>
                 </a:solidFill>
                 <a:latin typeface="Calibri"/>
               </a:rPr>
@@ -16200,7 +16234,7 @@
             <a:r>
               <a:rPr sz="1100" b="1" i="0">
                 <a:solidFill>
-                  <a:srgbClr val="FFFFFF"/>
+                  <a:srgbClr val="0B5E57"/>
                 </a:solidFill>
                 <a:latin typeface="Calibri"/>
               </a:rPr>
@@ -16218,7 +16252,7 @@
         <p:spPr>
           <a:xfrm>
             <a:off x="4315968" y="1463040"/>
-            <a:ext cx="1161288" cy="1143000"/>
+            <a:ext cx="1161288" cy="640080"/>
           </a:xfrm>
           <a:prstGeom prst="chevron">
             <a:avLst/>
@@ -16246,8 +16280,8 @@
         </p:nvSpPr>
         <p:spPr>
           <a:xfrm>
-            <a:off x="4480560" y="1572768"/>
-            <a:ext cx="886968" cy="365760"/>
+            <a:off x="4453128" y="1572768"/>
+            <a:ext cx="886968" cy="411480"/>
           </a:xfrm>
           <a:prstGeom prst="rect">
             <a:avLst/>
@@ -16281,8 +16315,8 @@
         </p:nvSpPr>
         <p:spPr>
           <a:xfrm>
-            <a:off x="4480560" y="1938528"/>
-            <a:ext cx="886968" cy="640080"/>
+            <a:off x="4270248" y="2148840"/>
+            <a:ext cx="1252728" cy="502920"/>
           </a:xfrm>
           <a:prstGeom prst="rect">
             <a:avLst/>
@@ -16299,7 +16333,7 @@
             <a:r>
               <a:rPr sz="1100" b="1" i="0">
                 <a:solidFill>
-                  <a:srgbClr val="FFFFFF"/>
+                  <a:srgbClr val="0B5E57"/>
                 </a:solidFill>
                 <a:latin typeface="Calibri"/>
               </a:rPr>
@@ -16311,7 +16345,7 @@
             <a:r>
               <a:rPr sz="1100" b="1" i="0">
                 <a:solidFill>
-                  <a:srgbClr val="FFFFFF"/>
+                  <a:srgbClr val="0B5E57"/>
                 </a:solidFill>
                 <a:latin typeface="Calibri"/>
               </a:rPr>
@@ -16329,7 +16363,7 @@
         <p:spPr>
           <a:xfrm>
             <a:off x="5586984" y="1463040"/>
-            <a:ext cx="1161288" cy="1143000"/>
+            <a:ext cx="1161288" cy="640080"/>
           </a:xfrm>
           <a:prstGeom prst="chevron">
             <a:avLst/>
@@ -16357,8 +16391,8 @@
         </p:nvSpPr>
         <p:spPr>
           <a:xfrm>
-            <a:off x="5751576" y="1572768"/>
-            <a:ext cx="886968" cy="365760"/>
+            <a:off x="5724144" y="1572768"/>
+            <a:ext cx="886968" cy="411480"/>
           </a:xfrm>
           <a:prstGeom prst="rect">
             <a:avLst/>
@@ -16392,8 +16426,8 @@
         </p:nvSpPr>
         <p:spPr>
           <a:xfrm>
-            <a:off x="5751576" y="1938528"/>
-            <a:ext cx="886968" cy="640080"/>
+            <a:off x="5541264" y="2148840"/>
+            <a:ext cx="1252728" cy="502920"/>
           </a:xfrm>
           <a:prstGeom prst="rect">
             <a:avLst/>
@@ -16410,7 +16444,7 @@
             <a:r>
               <a:rPr sz="1100" b="1" i="0">
                 <a:solidFill>
-                  <a:srgbClr val="FFFFFF"/>
+                  <a:srgbClr val="0B5E57"/>
                 </a:solidFill>
                 <a:latin typeface="Calibri"/>
               </a:rPr>
@@ -16422,7 +16456,7 @@
             <a:r>
               <a:rPr sz="1100" b="1" i="0">
                 <a:solidFill>
-                  <a:srgbClr val="FFFFFF"/>
+                  <a:srgbClr val="0B5E57"/>
                 </a:solidFill>
                 <a:latin typeface="Calibri"/>
               </a:rPr>
@@ -16440,7 +16474,7 @@
         <p:spPr>
           <a:xfrm>
             <a:off x="6858000" y="1463040"/>
-            <a:ext cx="1161288" cy="1143000"/>
+            <a:ext cx="1161288" cy="640080"/>
           </a:xfrm>
           <a:prstGeom prst="chevron">
             <a:avLst/>
@@ -16468,8 +16502,8 @@
         </p:nvSpPr>
         <p:spPr>
           <a:xfrm>
-            <a:off x="7022592" y="1572768"/>
-            <a:ext cx="886968" cy="365760"/>
+            <a:off x="6995160" y="1572768"/>
+            <a:ext cx="886968" cy="411480"/>
           </a:xfrm>
           <a:prstGeom prst="rect">
             <a:avLst/>
@@ -16503,8 +16537,8 @@
         </p:nvSpPr>
         <p:spPr>
           <a:xfrm>
-            <a:off x="7022592" y="1938528"/>
-            <a:ext cx="886968" cy="640080"/>
+            <a:off x="6812280" y="2148840"/>
+            <a:ext cx="1252728" cy="502920"/>
           </a:xfrm>
           <a:prstGeom prst="rect">
             <a:avLst/>
@@ -16521,7 +16555,7 @@
             <a:r>
               <a:rPr sz="1100" b="1" i="0">
                 <a:solidFill>
-                  <a:srgbClr val="FFFFFF"/>
+                  <a:srgbClr val="0B5E57"/>
                 </a:solidFill>
                 <a:latin typeface="Calibri"/>
               </a:rPr>
@@ -16539,7 +16573,7 @@
         <p:spPr>
           <a:xfrm>
             <a:off x="8129016" y="1463040"/>
-            <a:ext cx="1161288" cy="1143000"/>
+            <a:ext cx="1161288" cy="640080"/>
           </a:xfrm>
           <a:prstGeom prst="chevron">
             <a:avLst/>
@@ -16567,8 +16601,8 @@
         </p:nvSpPr>
         <p:spPr>
           <a:xfrm>
-            <a:off x="8293608" y="1572768"/>
-            <a:ext cx="886968" cy="365760"/>
+            <a:off x="8266176" y="1572768"/>
+            <a:ext cx="886968" cy="411480"/>
           </a:xfrm>
           <a:prstGeom prst="rect">
             <a:avLst/>
@@ -16602,8 +16636,8 @@
         </p:nvSpPr>
         <p:spPr>
           <a:xfrm>
-            <a:off x="8293608" y="1938528"/>
-            <a:ext cx="886968" cy="640080"/>
+            <a:off x="8083296" y="2148840"/>
+            <a:ext cx="1252728" cy="502920"/>
           </a:xfrm>
           <a:prstGeom prst="rect">
             <a:avLst/>
@@ -16620,7 +16654,7 @@
             <a:r>
               <a:rPr sz="1100" b="1" i="0">
                 <a:solidFill>
-                  <a:srgbClr val="FFFFFF"/>
+                  <a:srgbClr val="0B5E57"/>
                 </a:solidFill>
                 <a:latin typeface="Calibri"/>
               </a:rPr>
@@ -16638,7 +16672,7 @@
         <p:spPr>
           <a:xfrm>
             <a:off x="9400032" y="1463040"/>
-            <a:ext cx="1161288" cy="1143000"/>
+            <a:ext cx="1161288" cy="640080"/>
           </a:xfrm>
           <a:prstGeom prst="chevron">
             <a:avLst/>
@@ -16666,8 +16700,8 @@
         </p:nvSpPr>
         <p:spPr>
           <a:xfrm>
-            <a:off x="9564624" y="1572768"/>
-            <a:ext cx="886968" cy="365760"/>
+            <a:off x="9537192" y="1572768"/>
+            <a:ext cx="886968" cy="411480"/>
           </a:xfrm>
           <a:prstGeom prst="rect">
             <a:avLst/>
@@ -16701,8 +16735,8 @@
         </p:nvSpPr>
         <p:spPr>
           <a:xfrm>
-            <a:off x="9564624" y="1938528"/>
-            <a:ext cx="886968" cy="640080"/>
+            <a:off x="9354312" y="2148840"/>
+            <a:ext cx="1252728" cy="502920"/>
           </a:xfrm>
           <a:prstGeom prst="rect">
             <a:avLst/>
@@ -16719,7 +16753,7 @@
             <a:r>
               <a:rPr sz="1100" b="1" i="0">
                 <a:solidFill>
-                  <a:srgbClr val="FFFFFF"/>
+                  <a:srgbClr val="0B5E57"/>
                 </a:solidFill>
                 <a:latin typeface="Calibri"/>
               </a:rPr>
@@ -16731,7 +16765,7 @@
             <a:r>
               <a:rPr sz="1100" b="1" i="0">
                 <a:solidFill>
-                  <a:srgbClr val="FFFFFF"/>
+                  <a:srgbClr val="0B5E57"/>
                 </a:solidFill>
                 <a:latin typeface="Calibri"/>
               </a:rPr>
@@ -16749,7 +16783,7 @@
         <p:spPr>
           <a:xfrm>
             <a:off x="10671048" y="1463040"/>
-            <a:ext cx="1161288" cy="1143000"/>
+            <a:ext cx="1161288" cy="640080"/>
           </a:xfrm>
           <a:prstGeom prst="chevron">
             <a:avLst/>
@@ -16777,8 +16811,8 @@
         </p:nvSpPr>
         <p:spPr>
           <a:xfrm>
-            <a:off x="10835640" y="1572768"/>
-            <a:ext cx="886968" cy="365760"/>
+            <a:off x="10808208" y="1572768"/>
+            <a:ext cx="886968" cy="411480"/>
           </a:xfrm>
           <a:prstGeom prst="rect">
             <a:avLst/>
@@ -16812,8 +16846,8 @@
         </p:nvSpPr>
         <p:spPr>
           <a:xfrm>
-            <a:off x="10835640" y="1938528"/>
-            <a:ext cx="886968" cy="640080"/>
+            <a:off x="10625328" y="2148840"/>
+            <a:ext cx="1252728" cy="502920"/>
           </a:xfrm>
           <a:prstGeom prst="rect">
             <a:avLst/>
@@ -16830,7 +16864,7 @@
             <a:r>
               <a:rPr sz="1100" b="1" i="0">
                 <a:solidFill>
-                  <a:srgbClr val="FFFFFF"/>
+                  <a:srgbClr val="0B5E57"/>
                 </a:solidFill>
                 <a:latin typeface="Calibri"/>
               </a:rPr>
@@ -17628,7 +17662,7 @@
         </p:nvGraphicFramePr>
         <p:xfrm>
           <a:off x="502920" y="1188720"/>
-          <a:ext cx="11155680" cy="4114800"/>
+          <a:ext cx="11155680" cy="4206240"/>
         </p:xfrm>
         <a:graphic>
           <a:graphicData uri="http://schemas.openxmlformats.org/drawingml/2006/table">
@@ -17642,7 +17676,7 @@
                 <a:gridCol w="4480560"/>
                 <a:gridCol w="2834640"/>
               </a:tblGrid>
-              <a:tr h="457200">
+              <a:tr h="420624">
                 <a:tc>
                   <a:txBody>
                     <a:bodyPr wrap="square"/>
@@ -17732,7 +17766,7 @@
                   </a:tcPr>
                 </a:tc>
               </a:tr>
-              <a:tr h="457200">
+              <a:tr h="420624">
                 <a:tc>
                   <a:txBody>
                     <a:bodyPr wrap="square"/>
@@ -17822,7 +17856,7 @@
                   </a:tcPr>
                 </a:tc>
               </a:tr>
-              <a:tr h="457200">
+              <a:tr h="420624">
                 <a:tc>
                   <a:txBody>
                     <a:bodyPr wrap="square"/>
@@ -17835,7 +17869,7 @@
                           </a:solidFill>
                           <a:latin typeface="Calibri"/>
                         </a:rPr>
-                        <a:t>Waiter / host</a:t>
+                        <a:t>Customer at counter</a:t>
                       </a:r>
                     </a:p>
                   </a:txBody>
@@ -17857,7 +17891,7 @@
                           </a:solidFill>
                           <a:latin typeface="Calibri"/>
                         </a:rPr>
-                        <a:t>Tablet — Table map</a:t>
+                        <a:t>2nd monitor — Customer display</a:t>
                       </a:r>
                     </a:p>
                   </a:txBody>
@@ -17879,7 +17913,7 @@
                           </a:solidFill>
                           <a:latin typeface="Calibri"/>
                         </a:rPr>
-                        <a:t>Seat guests, send rounds to kitchen, move table, settle bill</a:t>
+                        <a:t>Sees items, offers, total, change and FBR QR as the cashier rings up</a:t>
                       </a:r>
                     </a:p>
                   </a:txBody>
@@ -17901,7 +17935,7 @@
                           </a:solidFill>
                           <a:latin typeface="Calibri"/>
                         </a:rPr>
-                        <a:t>Restaurant Order write</a:t>
+                        <a:t>None (mirrors the terminal on the same PC)</a:t>
                       </a:r>
                     </a:p>
                   </a:txBody>
@@ -17912,7 +17946,7 @@
                   </a:tcPr>
                 </a:tc>
               </a:tr>
-              <a:tr h="457200">
+              <a:tr h="420624">
                 <a:tc>
                   <a:txBody>
                     <a:bodyPr wrap="square"/>
@@ -17925,7 +17959,7 @@
                           </a:solidFill>
                           <a:latin typeface="Calibri"/>
                         </a:rPr>
-                        <a:t>Kitchen staff</a:t>
+                        <a:t>Waiter / host</a:t>
                       </a:r>
                     </a:p>
                   </a:txBody>
@@ -17947,7 +17981,7 @@
                           </a:solidFill>
                           <a:latin typeface="Calibri"/>
                         </a:rPr>
-                        <a:t>Wall screen — KDS</a:t>
+                        <a:t>Tablet — Table map</a:t>
                       </a:r>
                     </a:p>
                   </a:txBody>
@@ -17969,7 +18003,7 @@
                           </a:solidFill>
                           <a:latin typeface="Calibri"/>
                         </a:rPr>
-                        <a:t>See tickets by station, bump lines, recall, assign rider</a:t>
+                        <a:t>Seat guests, send rounds to kitchen, move table, settle bill</a:t>
                       </a:r>
                     </a:p>
                   </a:txBody>
@@ -17991,7 +18025,7 @@
                           </a:solidFill>
                           <a:latin typeface="Calibri"/>
                         </a:rPr>
-                        <a:t>Restaurant Order read</a:t>
+                        <a:t>Restaurant Order write</a:t>
                       </a:r>
                     </a:p>
                   </a:txBody>
@@ -18002,7 +18036,7 @@
                   </a:tcPr>
                 </a:tc>
               </a:tr>
-              <a:tr h="457200">
+              <a:tr h="420624">
                 <a:tc>
                   <a:txBody>
                     <a:bodyPr wrap="square"/>
@@ -18015,7 +18049,7 @@
                           </a:solidFill>
                           <a:latin typeface="Calibri"/>
                         </a:rPr>
-                        <a:t>Dispatcher</a:t>
+                        <a:t>Kitchen staff</a:t>
                       </a:r>
                     </a:p>
                   </a:txBody>
@@ -18037,7 +18071,7 @@
                           </a:solidFill>
                           <a:latin typeface="Calibri"/>
                         </a:rPr>
-                        <a:t>PC — Dispatch map</a:t>
+                        <a:t>Wall screen — KDS</a:t>
                       </a:r>
                     </a:p>
                   </a:txBody>
@@ -18059,7 +18093,7 @@
                           </a:solidFill>
                           <a:latin typeface="Calibri"/>
                         </a:rPr>
-                        <a:t>Phone orders, assign riders, collect rider cash</a:t>
+                        <a:t>See tickets by station, bump lines, recall, assign rider</a:t>
                       </a:r>
                     </a:p>
                   </a:txBody>
@@ -18081,7 +18115,7 @@
                           </a:solidFill>
                           <a:latin typeface="Calibri"/>
                         </a:rPr>
-                        <a:t>Restaurant Order write</a:t>
+                        <a:t>Restaurant Order read</a:t>
                       </a:r>
                     </a:p>
                   </a:txBody>
@@ -18092,7 +18126,7 @@
                   </a:tcPr>
                 </a:tc>
               </a:tr>
-              <a:tr h="457200">
+              <a:tr h="420624">
                 <a:tc>
                   <a:txBody>
                     <a:bodyPr wrap="square"/>
@@ -18105,7 +18139,7 @@
                           </a:solidFill>
                           <a:latin typeface="Calibri"/>
                         </a:rPr>
-                        <a:t>Rider</a:t>
+                        <a:t>Dispatcher</a:t>
                       </a:r>
                     </a:p>
                   </a:txBody>
@@ -18127,7 +18161,7 @@
                           </a:solidFill>
                           <a:latin typeface="Calibri"/>
                         </a:rPr>
-                        <a:t>Phone — Rider app</a:t>
+                        <a:t>PC — Dispatch map</a:t>
                       </a:r>
                     </a:p>
                   </a:txBody>
@@ -18149,7 +18183,7 @@
                           </a:solidFill>
                           <a:latin typeface="Calibri"/>
                         </a:rPr>
-                        <a:t>Go on duty, accept / reject, pick up, deliver (code, photo, cash)</a:t>
+                        <a:t>Phone orders, assign riders, collect rider cash</a:t>
                       </a:r>
                     </a:p>
                   </a:txBody>
@@ -18171,7 +18205,7 @@
                           </a:solidFill>
                           <a:latin typeface="Calibri"/>
                         </a:rPr>
-                        <a:t>Own deliveries only</a:t>
+                        <a:t>Restaurant Order write</a:t>
                       </a:r>
                     </a:p>
                   </a:txBody>
@@ -18182,7 +18216,7 @@
                   </a:tcPr>
                 </a:tc>
               </a:tr>
-              <a:tr h="457200">
+              <a:tr h="420624">
                 <a:tc>
                   <a:txBody>
                     <a:bodyPr wrap="square"/>
@@ -18195,7 +18229,7 @@
                           </a:solidFill>
                           <a:latin typeface="Calibri"/>
                         </a:rPr>
-                        <a:t>Customer</a:t>
+                        <a:t>Rider</a:t>
                       </a:r>
                     </a:p>
                   </a:txBody>
@@ -18217,7 +18251,7 @@
                           </a:solidFill>
                           <a:latin typeface="Calibri"/>
                         </a:rPr>
-                        <a:t>Phone / web — Ordering site, tracking</a:t>
+                        <a:t>Phone — Rider app</a:t>
                       </a:r>
                     </a:p>
                   </a:txBody>
@@ -18239,7 +18273,187 @@
                           </a:solidFill>
                           <a:latin typeface="Calibri"/>
                         </a:rPr>
+                        <a:t>Go on duty, accept / reject, pick up, deliver (code, photo, cash)</a:t>
+                      </a:r>
+                    </a:p>
+                  </a:txBody>
+                  <a:tcPr marL="64008" marR="64008" marT="27432" marB="27432" anchor="ctr">
+                    <a:solidFill>
+                      <a:srgbClr val="F8FAFC"/>
+                    </a:solidFill>
+                  </a:tcPr>
+                </a:tc>
+                <a:tc>
+                  <a:txBody>
+                    <a:bodyPr wrap="square"/>
+                    <a:lstStyle/>
+                    <a:p>
+                      <a:r>
+                        <a:rPr sz="1100" b="0" i="0">
+                          <a:solidFill>
+                            <a:srgbClr val="1E293B"/>
+                          </a:solidFill>
+                          <a:latin typeface="Calibri"/>
+                        </a:rPr>
+                        <a:t>Own deliveries only</a:t>
+                      </a:r>
+                    </a:p>
+                  </a:txBody>
+                  <a:tcPr marL="64008" marR="64008" marT="27432" marB="27432" anchor="ctr">
+                    <a:solidFill>
+                      <a:srgbClr val="F8FAFC"/>
+                    </a:solidFill>
+                  </a:tcPr>
+                </a:tc>
+              </a:tr>
+              <a:tr h="420624">
+                <a:tc>
+                  <a:txBody>
+                    <a:bodyPr wrap="square"/>
+                    <a:lstStyle/>
+                    <a:p>
+                      <a:r>
+                        <a:rPr sz="1100" b="1" i="0">
+                          <a:solidFill>
+                            <a:srgbClr val="1E293B"/>
+                          </a:solidFill>
+                          <a:latin typeface="Calibri"/>
+                        </a:rPr>
+                        <a:t>Customer</a:t>
+                      </a:r>
+                    </a:p>
+                  </a:txBody>
+                  <a:tcPr marL="64008" marR="64008" marT="27432" marB="27432" anchor="ctr">
+                    <a:solidFill>
+                      <a:srgbClr val="FFFFFF"/>
+                    </a:solidFill>
+                  </a:tcPr>
+                </a:tc>
+                <a:tc>
+                  <a:txBody>
+                    <a:bodyPr wrap="square"/>
+                    <a:lstStyle/>
+                    <a:p>
+                      <a:r>
+                        <a:rPr sz="1100" b="0" i="0">
+                          <a:solidFill>
+                            <a:srgbClr val="1E293B"/>
+                          </a:solidFill>
+                          <a:latin typeface="Calibri"/>
+                        </a:rPr>
+                        <a:t>Phone / web — Ordering site, tracking</a:t>
+                      </a:r>
+                    </a:p>
+                  </a:txBody>
+                  <a:tcPr marL="64008" marR="64008" marT="27432" marB="27432" anchor="ctr">
+                    <a:solidFill>
+                      <a:srgbClr val="FFFFFF"/>
+                    </a:solidFill>
+                  </a:tcPr>
+                </a:tc>
+                <a:tc>
+                  <a:txBody>
+                    <a:bodyPr wrap="square"/>
+                    <a:lstStyle/>
+                    <a:p>
+                      <a:r>
+                        <a:rPr sz="1100" b="0" i="0">
+                          <a:solidFill>
+                            <a:srgbClr val="1E293B"/>
+                          </a:solidFill>
+                          <a:latin typeface="Calibri"/>
+                        </a:rPr>
                         <a:t>Order, pay, track rider, rate order, earn points</a:t>
+                      </a:r>
+                    </a:p>
+                  </a:txBody>
+                  <a:tcPr marL="64008" marR="64008" marT="27432" marB="27432" anchor="ctr">
+                    <a:solidFill>
+                      <a:srgbClr val="FFFFFF"/>
+                    </a:solidFill>
+                  </a:tcPr>
+                </a:tc>
+                <a:tc>
+                  <a:txBody>
+                    <a:bodyPr wrap="square"/>
+                    <a:lstStyle/>
+                    <a:p>
+                      <a:r>
+                        <a:rPr sz="1100" b="0" i="0">
+                          <a:solidFill>
+                            <a:srgbClr val="1E293B"/>
+                          </a:solidFill>
+                          <a:latin typeface="Calibri"/>
+                        </a:rPr>
+                        <a:t>Public, rate limited</a:t>
+                      </a:r>
+                    </a:p>
+                  </a:txBody>
+                  <a:tcPr marL="64008" marR="64008" marT="27432" marB="27432" anchor="ctr">
+                    <a:solidFill>
+                      <a:srgbClr val="FFFFFF"/>
+                    </a:solidFill>
+                  </a:tcPr>
+                </a:tc>
+              </a:tr>
+              <a:tr h="420624">
+                <a:tc>
+                  <a:txBody>
+                    <a:bodyPr wrap="square"/>
+                    <a:lstStyle/>
+                    <a:p>
+                      <a:r>
+                        <a:rPr sz="1100" b="1" i="0">
+                          <a:solidFill>
+                            <a:srgbClr val="1E293B"/>
+                          </a:solidFill>
+                          <a:latin typeface="Calibri"/>
+                        </a:rPr>
+                        <a:t>Walk-in guest</a:t>
+                      </a:r>
+                    </a:p>
+                  </a:txBody>
+                  <a:tcPr marL="64008" marR="64008" marT="27432" marB="27432" anchor="ctr">
+                    <a:solidFill>
+                      <a:srgbClr val="F8FAFC"/>
+                    </a:solidFill>
+                  </a:tcPr>
+                </a:tc>
+                <a:tc>
+                  <a:txBody>
+                    <a:bodyPr wrap="square"/>
+                    <a:lstStyle/>
+                    <a:p>
+                      <a:r>
+                        <a:rPr sz="1100" b="0" i="0">
+                          <a:solidFill>
+                            <a:srgbClr val="1E293B"/>
+                          </a:solidFill>
+                          <a:latin typeface="Calibri"/>
+                        </a:rPr>
+                        <a:t>Tablet — Kiosk</a:t>
+                      </a:r>
+                    </a:p>
+                  </a:txBody>
+                  <a:tcPr marL="64008" marR="64008" marT="27432" marB="27432" anchor="ctr">
+                    <a:solidFill>
+                      <a:srgbClr val="F8FAFC"/>
+                    </a:solidFill>
+                  </a:tcPr>
+                </a:tc>
+                <a:tc>
+                  <a:txBody>
+                    <a:bodyPr wrap="square"/>
+                    <a:lstStyle/>
+                    <a:p>
+                      <a:r>
+                        <a:rPr sz="1100" b="0" i="0">
+                          <a:solidFill>
+                            <a:srgbClr val="1E293B"/>
+                          </a:solidFill>
+                          <a:latin typeface="Calibri"/>
+                        </a:rPr>
+                        <a:t>Self-order; pay at counter</a:t>
                       </a:r>
                     </a:p>
                   </a:txBody>
@@ -18272,7 +18486,7 @@
                   </a:tcPr>
                 </a:tc>
               </a:tr>
-              <a:tr h="457200">
+              <a:tr h="420624">
                 <a:tc>
                   <a:txBody>
                     <a:bodyPr wrap="square"/>
@@ -18285,7 +18499,7 @@
                           </a:solidFill>
                           <a:latin typeface="Calibri"/>
                         </a:rPr>
-                        <a:t>Walk-in guest</a:t>
+                        <a:t>Manager / owner</a:t>
                       </a:r>
                     </a:p>
                   </a:txBody>
@@ -18307,7 +18521,7 @@
                           </a:solidFill>
                           <a:latin typeface="Calibri"/>
                         </a:rPr>
-                        <a:t>Tablet — Kiosk</a:t>
+                        <a:t>Any — Dashboard, reports</a:t>
                       </a:r>
                     </a:p>
                   </a:txBody>
@@ -18329,7 +18543,7 @@
                           </a:solidFill>
                           <a:latin typeface="Calibri"/>
                         </a:rPr>
-                        <a:t>Self-order; pay at counter</a:t>
+                        <a:t>Approve big discounts &amp; returns, reviews, campaigns, settings</a:t>
                       </a:r>
                     </a:p>
                   </a:txBody>
@@ -18351,103 +18565,13 @@
                           </a:solidFill>
                           <a:latin typeface="Calibri"/>
                         </a:rPr>
-                        <a:t>Public, rate limited</a:t>
+                        <a:t>System / Sales / Accounts Manager</a:t>
                       </a:r>
                     </a:p>
                   </a:txBody>
                   <a:tcPr marL="64008" marR="64008" marT="27432" marB="27432" anchor="ctr">
                     <a:solidFill>
                       <a:srgbClr val="FFFFFF"/>
-                    </a:solidFill>
-                  </a:tcPr>
-                </a:tc>
-              </a:tr>
-              <a:tr h="457200">
-                <a:tc>
-                  <a:txBody>
-                    <a:bodyPr wrap="square"/>
-                    <a:lstStyle/>
-                    <a:p>
-                      <a:r>
-                        <a:rPr sz="1100" b="1" i="0">
-                          <a:solidFill>
-                            <a:srgbClr val="1E293B"/>
-                          </a:solidFill>
-                          <a:latin typeface="Calibri"/>
-                        </a:rPr>
-                        <a:t>Manager / owner</a:t>
-                      </a:r>
-                    </a:p>
-                  </a:txBody>
-                  <a:tcPr marL="64008" marR="64008" marT="27432" marB="27432" anchor="ctr">
-                    <a:solidFill>
-                      <a:srgbClr val="F8FAFC"/>
-                    </a:solidFill>
-                  </a:tcPr>
-                </a:tc>
-                <a:tc>
-                  <a:txBody>
-                    <a:bodyPr wrap="square"/>
-                    <a:lstStyle/>
-                    <a:p>
-                      <a:r>
-                        <a:rPr sz="1100" b="0" i="0">
-                          <a:solidFill>
-                            <a:srgbClr val="1E293B"/>
-                          </a:solidFill>
-                          <a:latin typeface="Calibri"/>
-                        </a:rPr>
-                        <a:t>Any — Dashboard, reports</a:t>
-                      </a:r>
-                    </a:p>
-                  </a:txBody>
-                  <a:tcPr marL="64008" marR="64008" marT="27432" marB="27432" anchor="ctr">
-                    <a:solidFill>
-                      <a:srgbClr val="F8FAFC"/>
-                    </a:solidFill>
-                  </a:tcPr>
-                </a:tc>
-                <a:tc>
-                  <a:txBody>
-                    <a:bodyPr wrap="square"/>
-                    <a:lstStyle/>
-                    <a:p>
-                      <a:r>
-                        <a:rPr sz="1100" b="0" i="0">
-                          <a:solidFill>
-                            <a:srgbClr val="1E293B"/>
-                          </a:solidFill>
-                          <a:latin typeface="Calibri"/>
-                        </a:rPr>
-                        <a:t>Approve big discounts &amp; returns, reviews, campaigns, settings</a:t>
-                      </a:r>
-                    </a:p>
-                  </a:txBody>
-                  <a:tcPr marL="64008" marR="64008" marT="27432" marB="27432" anchor="ctr">
-                    <a:solidFill>
-                      <a:srgbClr val="F8FAFC"/>
-                    </a:solidFill>
-                  </a:tcPr>
-                </a:tc>
-                <a:tc>
-                  <a:txBody>
-                    <a:bodyPr wrap="square"/>
-                    <a:lstStyle/>
-                    <a:p>
-                      <a:r>
-                        <a:rPr sz="1100" b="0" i="0">
-                          <a:solidFill>
-                            <a:srgbClr val="1E293B"/>
-                          </a:solidFill>
-                          <a:latin typeface="Calibri"/>
-                        </a:rPr>
-                        <a:t>System / Sales / Accounts Manager</a:t>
-                      </a:r>
-                    </a:p>
-                  </a:txBody>
-                  <a:tcPr marL="64008" marR="64008" marT="27432" marB="27432" anchor="ctr">
-                    <a:solidFill>
-                      <a:srgbClr val="F8FAFC"/>
                     </a:solidFill>
                   </a:tcPr>
                 </a:tc>
@@ -18761,7 +18885,7 @@
         <p:spPr>
           <a:xfrm>
             <a:off x="640080" y="1618488"/>
-            <a:ext cx="1264158" cy="530352"/>
+            <a:ext cx="1111504" cy="530352"/>
           </a:xfrm>
           <a:prstGeom prst="rect">
             <a:avLst/>
@@ -18800,8 +18924,8 @@
         </p:nvSpPr>
         <p:spPr>
           <a:xfrm>
-            <a:off x="2013966" y="1618488"/>
-            <a:ext cx="1264158" cy="530352"/>
+            <a:off x="1861312" y="1618488"/>
+            <a:ext cx="1111504" cy="530352"/>
           </a:xfrm>
           <a:prstGeom prst="rect">
             <a:avLst/>
@@ -18827,7 +18951,7 @@
                 </a:solidFill>
                 <a:latin typeface="Calibri"/>
               </a:rPr>
-              <a:t>Table map</a:t>
+              <a:t>Customer display</a:t>
             </a:r>
           </a:p>
         </p:txBody>
@@ -18840,8 +18964,8 @@
         </p:nvSpPr>
         <p:spPr>
           <a:xfrm>
-            <a:off x="3387852" y="1618488"/>
-            <a:ext cx="1264158" cy="530352"/>
+            <a:off x="3082544" y="1618488"/>
+            <a:ext cx="1111504" cy="530352"/>
           </a:xfrm>
           <a:prstGeom prst="rect">
             <a:avLst/>
@@ -18867,7 +18991,7 @@
                 </a:solidFill>
                 <a:latin typeface="Calibri"/>
               </a:rPr>
-              <a:t>KDS</a:t>
+              <a:t>Table map</a:t>
             </a:r>
           </a:p>
         </p:txBody>
@@ -18880,8 +19004,8 @@
         </p:nvSpPr>
         <p:spPr>
           <a:xfrm>
-            <a:off x="4761738" y="1618488"/>
-            <a:ext cx="1264158" cy="530352"/>
+            <a:off x="4303776" y="1618488"/>
+            <a:ext cx="1111504" cy="530352"/>
           </a:xfrm>
           <a:prstGeom prst="rect">
             <a:avLst/>
@@ -18907,7 +19031,7 @@
                 </a:solidFill>
                 <a:latin typeface="Calibri"/>
               </a:rPr>
-              <a:t>Dispatch</a:t>
+              <a:t>KDS</a:t>
             </a:r>
           </a:p>
         </p:txBody>
@@ -18920,8 +19044,8 @@
         </p:nvSpPr>
         <p:spPr>
           <a:xfrm>
-            <a:off x="6135624" y="1618488"/>
-            <a:ext cx="1264158" cy="530352"/>
+            <a:off x="5525008" y="1618488"/>
+            <a:ext cx="1111504" cy="530352"/>
           </a:xfrm>
           <a:prstGeom prst="rect">
             <a:avLst/>
@@ -18947,7 +19071,7 @@
                 </a:solidFill>
                 <a:latin typeface="Calibri"/>
               </a:rPr>
-              <a:t>Rider app</a:t>
+              <a:t>Dispatch</a:t>
             </a:r>
           </a:p>
         </p:txBody>
@@ -18960,8 +19084,8 @@
         </p:nvSpPr>
         <p:spPr>
           <a:xfrm>
-            <a:off x="7509510" y="1618488"/>
-            <a:ext cx="1264158" cy="530352"/>
+            <a:off x="6746240" y="1618488"/>
+            <a:ext cx="1111504" cy="530352"/>
           </a:xfrm>
           <a:prstGeom prst="rect">
             <a:avLst/>
@@ -18987,7 +19111,7 @@
                 </a:solidFill>
                 <a:latin typeface="Calibri"/>
               </a:rPr>
-              <a:t>Ordering site</a:t>
+              <a:t>Rider app</a:t>
             </a:r>
           </a:p>
         </p:txBody>
@@ -19000,8 +19124,8 @@
         </p:nvSpPr>
         <p:spPr>
           <a:xfrm>
-            <a:off x="8883396" y="1618488"/>
-            <a:ext cx="1264158" cy="530352"/>
+            <a:off x="7967472" y="1618488"/>
+            <a:ext cx="1111504" cy="530352"/>
           </a:xfrm>
           <a:prstGeom prst="rect">
             <a:avLst/>
@@ -19027,7 +19151,7 @@
                 </a:solidFill>
                 <a:latin typeface="Calibri"/>
               </a:rPr>
-              <a:t>Kiosk</a:t>
+              <a:t>Ordering site</a:t>
             </a:r>
           </a:p>
         </p:txBody>
@@ -19040,8 +19164,8 @@
         </p:nvSpPr>
         <p:spPr>
           <a:xfrm>
-            <a:off x="10257282" y="1618488"/>
-            <a:ext cx="1264158" cy="530352"/>
+            <a:off x="9188704" y="1618488"/>
+            <a:ext cx="1111504" cy="530352"/>
           </a:xfrm>
           <a:prstGeom prst="rect">
             <a:avLst/>
@@ -19067,6 +19191,46 @@
                 </a:solidFill>
                 <a:latin typeface="Calibri"/>
               </a:rPr>
+              <a:t>Kiosk</a:t>
+            </a:r>
+          </a:p>
+        </p:txBody>
+      </p:sp>
+      <p:sp>
+        <p:nvSpPr>
+          <p:cNvPr id="17" name="Rectangle 16"/>
+          <p:cNvSpPr/>
+          <p:nvPr/>
+        </p:nvSpPr>
+        <p:spPr>
+          <a:xfrm>
+            <a:off x="10409936" y="1618488"/>
+            <a:ext cx="1111504" cy="530352"/>
+          </a:xfrm>
+          <a:prstGeom prst="rect">
+            <a:avLst/>
+          </a:prstGeom>
+          <a:solidFill>
+            <a:srgbClr val="FFFFFF"/>
+          </a:solidFill>
+          <a:ln w="12700">
+            <a:solidFill>
+              <a:srgbClr val="2A78D6"/>
+            </a:solidFill>
+          </a:ln>
+        </p:spPr>
+        <p:txBody>
+          <a:bodyPr rtlCol="0" anchor="ctr" wrap="square" lIns="54864" rIns="54864" tIns="27432" bIns="27432"/>
+          <a:lstStyle/>
+          <a:p>
+            <a:pPr algn="ctr"/>
+            <a:r>
+              <a:rPr sz="1100" b="1" i="0">
+                <a:solidFill>
+                  <a:srgbClr val="1E293B"/>
+                </a:solidFill>
+                <a:latin typeface="Calibri"/>
+              </a:rPr>
               <a:t>Owner dashboard</a:t>
             </a:r>
           </a:p>
@@ -19074,7 +19238,7 @@
       </p:sp>
       <p:sp>
         <p:nvSpPr>
-          <p:cNvPr id="17" name="Rectangle 16"/>
+          <p:cNvPr id="18" name="Rectangle 17"/>
           <p:cNvSpPr/>
           <p:nvPr/>
         </p:nvSpPr>
@@ -19105,7 +19269,7 @@
       </p:sp>
       <p:sp>
         <p:nvSpPr>
-          <p:cNvPr id="18" name="TextBox 17"/>
+          <p:cNvPr id="19" name="TextBox 18"/>
           <p:cNvSpPr txBox="1"/>
           <p:nvPr/>
         </p:nvSpPr>
@@ -19140,7 +19304,7 @@
       </p:sp>
       <p:sp>
         <p:nvSpPr>
-          <p:cNvPr id="19" name="Rectangle 18"/>
+          <p:cNvPr id="20" name="Rectangle 19"/>
           <p:cNvSpPr/>
           <p:nvPr/>
         </p:nvSpPr>
@@ -19180,7 +19344,7 @@
       </p:sp>
       <p:sp>
         <p:nvSpPr>
-          <p:cNvPr id="20" name="Rectangle 19"/>
+          <p:cNvPr id="21" name="Rectangle 20"/>
           <p:cNvSpPr/>
           <p:nvPr/>
         </p:nvSpPr>
@@ -19220,7 +19384,7 @@
       </p:sp>
       <p:sp>
         <p:nvSpPr>
-          <p:cNvPr id="21" name="Rectangle 20"/>
+          <p:cNvPr id="22" name="Rectangle 21"/>
           <p:cNvSpPr/>
           <p:nvPr/>
         </p:nvSpPr>
@@ -19260,7 +19424,7 @@
       </p:sp>
       <p:sp>
         <p:nvSpPr>
-          <p:cNvPr id="22" name="Rectangle 21"/>
+          <p:cNvPr id="23" name="Rectangle 22"/>
           <p:cNvSpPr/>
           <p:nvPr/>
         </p:nvSpPr>
@@ -19300,7 +19464,7 @@
       </p:sp>
       <p:sp>
         <p:nvSpPr>
-          <p:cNvPr id="23" name="Rectangle 22"/>
+          <p:cNvPr id="24" name="Rectangle 23"/>
           <p:cNvSpPr/>
           <p:nvPr/>
         </p:nvSpPr>
@@ -19340,7 +19504,7 @@
       </p:sp>
       <p:sp>
         <p:nvSpPr>
-          <p:cNvPr id="24" name="Rectangle 23"/>
+          <p:cNvPr id="25" name="Rectangle 24"/>
           <p:cNvSpPr/>
           <p:nvPr/>
         </p:nvSpPr>
@@ -19380,7 +19544,7 @@
       </p:sp>
       <p:sp>
         <p:nvSpPr>
-          <p:cNvPr id="25" name="Rectangle 24"/>
+          <p:cNvPr id="26" name="Rectangle 25"/>
           <p:cNvSpPr/>
           <p:nvPr/>
         </p:nvSpPr>
@@ -19420,7 +19584,7 @@
       </p:sp>
       <p:sp>
         <p:nvSpPr>
-          <p:cNvPr id="26" name="Rectangle 25"/>
+          <p:cNvPr id="27" name="Rectangle 26"/>
           <p:cNvSpPr/>
           <p:nvPr/>
         </p:nvSpPr>
@@ -19460,7 +19624,7 @@
       </p:sp>
       <p:sp>
         <p:nvSpPr>
-          <p:cNvPr id="27" name="Rectangle 26"/>
+          <p:cNvPr id="28" name="Rectangle 27"/>
           <p:cNvSpPr/>
           <p:nvPr/>
         </p:nvSpPr>
@@ -19491,7 +19655,7 @@
       </p:sp>
       <p:sp>
         <p:nvSpPr>
-          <p:cNvPr id="28" name="TextBox 27"/>
+          <p:cNvPr id="29" name="TextBox 28"/>
           <p:cNvSpPr txBox="1"/>
           <p:nvPr/>
         </p:nvSpPr>
@@ -19526,7 +19690,7 @@
       </p:sp>
       <p:sp>
         <p:nvSpPr>
-          <p:cNvPr id="29" name="Rectangle 28"/>
+          <p:cNvPr id="30" name="Rectangle 29"/>
           <p:cNvSpPr/>
           <p:nvPr/>
         </p:nvSpPr>
@@ -19566,7 +19730,7 @@
       </p:sp>
       <p:sp>
         <p:nvSpPr>
-          <p:cNvPr id="30" name="Rectangle 29"/>
+          <p:cNvPr id="31" name="Rectangle 30"/>
           <p:cNvSpPr/>
           <p:nvPr/>
         </p:nvSpPr>
@@ -19606,7 +19770,7 @@
       </p:sp>
       <p:sp>
         <p:nvSpPr>
-          <p:cNvPr id="31" name="Rectangle 30"/>
+          <p:cNvPr id="32" name="Rectangle 31"/>
           <p:cNvSpPr/>
           <p:nvPr/>
         </p:nvSpPr>
@@ -19646,7 +19810,7 @@
       </p:sp>
       <p:sp>
         <p:nvSpPr>
-          <p:cNvPr id="32" name="Rectangle 31"/>
+          <p:cNvPr id="33" name="Rectangle 32"/>
           <p:cNvSpPr/>
           <p:nvPr/>
         </p:nvSpPr>
@@ -19686,7 +19850,7 @@
       </p:sp>
       <p:sp>
         <p:nvSpPr>
-          <p:cNvPr id="33" name="Rectangle 32"/>
+          <p:cNvPr id="34" name="Rectangle 33"/>
           <p:cNvSpPr/>
           <p:nvPr/>
         </p:nvSpPr>
@@ -19726,7 +19890,7 @@
       </p:sp>
       <p:sp>
         <p:nvSpPr>
-          <p:cNvPr id="34" name="Rectangle 33"/>
+          <p:cNvPr id="35" name="Rectangle 34"/>
           <p:cNvSpPr/>
           <p:nvPr/>
         </p:nvSpPr>
@@ -19766,7 +19930,7 @@
       </p:sp>
       <p:sp>
         <p:nvSpPr>
-          <p:cNvPr id="35" name="Rectangle 34"/>
+          <p:cNvPr id="36" name="Rectangle 35"/>
           <p:cNvSpPr/>
           <p:nvPr/>
         </p:nvSpPr>
@@ -19806,7 +19970,7 @@
       </p:sp>
       <p:sp>
         <p:nvSpPr>
-          <p:cNvPr id="36" name="Rectangle 35"/>
+          <p:cNvPr id="37" name="Rectangle 36"/>
           <p:cNvSpPr/>
           <p:nvPr/>
         </p:nvSpPr>
@@ -19846,7 +20010,7 @@
       </p:sp>
       <p:sp>
         <p:nvSpPr>
-          <p:cNvPr id="37" name="Rectangle 36"/>
+          <p:cNvPr id="38" name="Rectangle 37"/>
           <p:cNvSpPr/>
           <p:nvPr/>
         </p:nvSpPr>
@@ -19877,7 +20041,7 @@
       </p:sp>
       <p:sp>
         <p:nvSpPr>
-          <p:cNvPr id="38" name="TextBox 37"/>
+          <p:cNvPr id="39" name="TextBox 38"/>
           <p:cNvSpPr txBox="1"/>
           <p:nvPr/>
         </p:nvSpPr>
@@ -19912,7 +20076,7 @@
       </p:sp>
       <p:sp>
         <p:nvSpPr>
-          <p:cNvPr id="39" name="Rectangle 38"/>
+          <p:cNvPr id="40" name="Rectangle 39"/>
           <p:cNvSpPr/>
           <p:nvPr/>
         </p:nvSpPr>
@@ -19952,7 +20116,7 @@
       </p:sp>
       <p:sp>
         <p:nvSpPr>
-          <p:cNvPr id="40" name="Rectangle 39"/>
+          <p:cNvPr id="41" name="Rectangle 40"/>
           <p:cNvSpPr/>
           <p:nvPr/>
         </p:nvSpPr>
@@ -19992,7 +20156,7 @@
       </p:sp>
       <p:sp>
         <p:nvSpPr>
-          <p:cNvPr id="41" name="Rectangle 40"/>
+          <p:cNvPr id="42" name="Rectangle 41"/>
           <p:cNvSpPr/>
           <p:nvPr/>
         </p:nvSpPr>
@@ -20032,7 +20196,7 @@
       </p:sp>
       <p:sp>
         <p:nvSpPr>
-          <p:cNvPr id="42" name="Rectangle 41"/>
+          <p:cNvPr id="43" name="Rectangle 42"/>
           <p:cNvSpPr/>
           <p:nvPr/>
         </p:nvSpPr>
@@ -20072,7 +20236,7 @@
       </p:sp>
       <p:sp>
         <p:nvSpPr>
-          <p:cNvPr id="43" name="TextBox 42"/>
+          <p:cNvPr id="44" name="TextBox 43"/>
           <p:cNvSpPr txBox="1"/>
           <p:nvPr/>
         </p:nvSpPr>
@@ -24558,8 +24722,8 @@
         </p:nvSpPr>
         <p:spPr>
           <a:xfrm>
-            <a:off x="1892808" y="1046988"/>
-            <a:ext cx="457200" cy="219456"/>
+            <a:off x="1920240" y="1321308"/>
+            <a:ext cx="457200" cy="201168"/>
           </a:xfrm>
           <a:prstGeom prst="rect">
             <a:avLst/>
@@ -24569,12 +24733,12 @@
           </a:solidFill>
         </p:spPr>
         <p:txBody>
-          <a:bodyPr wrap="square" lIns="45720" rIns="45720" tIns="18288" bIns="18288" anchor="t">
+          <a:bodyPr wrap="none" lIns="45720" rIns="45720" tIns="18288" bIns="18288" anchor="t">
             <a:spAutoFit/>
           </a:bodyPr>
           <a:lstStyle/>
           <a:p>
-            <a:pPr algn="ctr"/>
+            <a:pPr algn="l"/>
             <a:r>
               <a:rPr sz="900" b="0" i="0">
                 <a:solidFill>
@@ -24618,7 +24782,7 @@
         <p:spPr>
           <a:xfrm>
             <a:off x="1828800" y="2007108"/>
-            <a:ext cx="731520" cy="219456"/>
+            <a:ext cx="731520" cy="201168"/>
           </a:xfrm>
           <a:prstGeom prst="rect">
             <a:avLst/>
@@ -24628,12 +24792,12 @@
           </a:solidFill>
         </p:spPr>
         <p:txBody>
-          <a:bodyPr wrap="square" lIns="45720" rIns="45720" tIns="18288" bIns="18288" anchor="t">
+          <a:bodyPr wrap="none" lIns="45720" rIns="45720" tIns="18288" bIns="18288" anchor="t">
             <a:spAutoFit/>
           </a:bodyPr>
           <a:lstStyle/>
           <a:p>
-            <a:pPr algn="ctr"/>
+            <a:pPr algn="l"/>
             <a:r>
               <a:rPr sz="900" b="0" i="0">
                 <a:solidFill>
@@ -24677,7 +24841,7 @@
         <p:spPr>
           <a:xfrm>
             <a:off x="1856232" y="2692908"/>
-            <a:ext cx="548640" cy="219456"/>
+            <a:ext cx="548640" cy="201168"/>
           </a:xfrm>
           <a:prstGeom prst="rect">
             <a:avLst/>
@@ -24687,12 +24851,12 @@
           </a:solidFill>
         </p:spPr>
         <p:txBody>
-          <a:bodyPr wrap="square" lIns="45720" rIns="45720" tIns="18288" bIns="18288" anchor="t">
+          <a:bodyPr wrap="none" lIns="45720" rIns="45720" tIns="18288" bIns="18288" anchor="t">
             <a:spAutoFit/>
           </a:bodyPr>
           <a:lstStyle/>
           <a:p>
-            <a:pPr algn="ctr"/>
+            <a:pPr algn="l"/>
             <a:r>
               <a:rPr sz="900" b="0" i="0">
                 <a:solidFill>
@@ -24736,7 +24900,7 @@
         <p:spPr>
           <a:xfrm>
             <a:off x="6903720" y="1051560"/>
-            <a:ext cx="822960" cy="219456"/>
+            <a:ext cx="822960" cy="201168"/>
           </a:xfrm>
           <a:prstGeom prst="rect">
             <a:avLst/>
@@ -24746,12 +24910,12 @@
           </a:solidFill>
         </p:spPr>
         <p:txBody>
-          <a:bodyPr wrap="square" lIns="45720" rIns="45720" tIns="18288" bIns="18288" anchor="t">
+          <a:bodyPr wrap="none" lIns="45720" rIns="45720" tIns="18288" bIns="18288" anchor="t">
             <a:spAutoFit/>
           </a:bodyPr>
           <a:lstStyle/>
           <a:p>
-            <a:pPr algn="ctr"/>
+            <a:pPr algn="l"/>
             <a:r>
               <a:rPr sz="900" b="0" i="0">
                 <a:solidFill>
@@ -24795,7 +24959,7 @@
         <p:spPr>
           <a:xfrm>
             <a:off x="2400299" y="2203704"/>
-            <a:ext cx="685800" cy="219456"/>
+            <a:ext cx="685800" cy="201168"/>
           </a:xfrm>
           <a:prstGeom prst="rect">
             <a:avLst/>
@@ -24805,12 +24969,12 @@
           </a:solidFill>
         </p:spPr>
         <p:txBody>
-          <a:bodyPr wrap="square" lIns="45720" rIns="45720" tIns="18288" bIns="18288" anchor="t">
+          <a:bodyPr wrap="none" lIns="45720" rIns="45720" tIns="18288" bIns="18288" anchor="t">
             <a:spAutoFit/>
           </a:bodyPr>
           <a:lstStyle/>
           <a:p>
-            <a:pPr algn="ctr"/>
+            <a:pPr algn="l"/>
             <a:r>
               <a:rPr sz="900" b="0" i="0">
                 <a:solidFill>
@@ -24854,7 +25018,7 @@
         <p:spPr>
           <a:xfrm>
             <a:off x="4480560" y="2185416"/>
-            <a:ext cx="457200" cy="219456"/>
+            <a:ext cx="457200" cy="201168"/>
           </a:xfrm>
           <a:prstGeom prst="rect">
             <a:avLst/>
@@ -24864,12 +25028,12 @@
           </a:solidFill>
         </p:spPr>
         <p:txBody>
-          <a:bodyPr wrap="square" lIns="45720" rIns="45720" tIns="18288" bIns="18288" anchor="t">
+          <a:bodyPr wrap="none" lIns="45720" rIns="45720" tIns="18288" bIns="18288" anchor="t">
             <a:spAutoFit/>
           </a:bodyPr>
           <a:lstStyle/>
           <a:p>
-            <a:pPr algn="ctr"/>
+            <a:pPr algn="l"/>
             <a:r>
               <a:rPr sz="900" b="0" i="0">
                 <a:solidFill>
@@ -24913,7 +25077,7 @@
         <p:spPr>
           <a:xfrm>
             <a:off x="4480559" y="1517904"/>
-            <a:ext cx="548640" cy="219456"/>
+            <a:ext cx="548640" cy="201168"/>
           </a:xfrm>
           <a:prstGeom prst="rect">
             <a:avLst/>
@@ -24923,12 +25087,12 @@
           </a:solidFill>
         </p:spPr>
         <p:txBody>
-          <a:bodyPr wrap="square" lIns="45720" rIns="45720" tIns="18288" bIns="18288" anchor="t">
+          <a:bodyPr wrap="none" lIns="45720" rIns="45720" tIns="18288" bIns="18288" anchor="t">
             <a:spAutoFit/>
           </a:bodyPr>
           <a:lstStyle/>
           <a:p>
-            <a:pPr algn="ctr"/>
+            <a:pPr algn="l"/>
             <a:r>
               <a:rPr sz="900" b="0" i="0">
                 <a:solidFill>
@@ -24973,7 +25137,7 @@
         <p:spPr>
           <a:xfrm>
             <a:off x="6195060" y="1024128"/>
-            <a:ext cx="1005840" cy="219456"/>
+            <a:ext cx="1005840" cy="201168"/>
           </a:xfrm>
           <a:prstGeom prst="rect">
             <a:avLst/>
@@ -24983,12 +25147,12 @@
           </a:solidFill>
         </p:spPr>
         <p:txBody>
-          <a:bodyPr wrap="square" lIns="45720" rIns="45720" tIns="18288" bIns="18288" anchor="t">
+          <a:bodyPr wrap="none" lIns="45720" rIns="45720" tIns="18288" bIns="18288" anchor="t">
             <a:spAutoFit/>
           </a:bodyPr>
           <a:lstStyle/>
           <a:p>
-            <a:pPr algn="ctr"/>
+            <a:pPr algn="l"/>
             <a:r>
               <a:rPr sz="900" b="0" i="0">
                 <a:solidFill>
@@ -25032,7 +25196,7 @@
         <p:spPr>
           <a:xfrm>
             <a:off x="4983480" y="2331720"/>
-            <a:ext cx="457200" cy="219456"/>
+            <a:ext cx="457200" cy="201168"/>
           </a:xfrm>
           <a:prstGeom prst="rect">
             <a:avLst/>
@@ -25042,12 +25206,12 @@
           </a:solidFill>
         </p:spPr>
         <p:txBody>
-          <a:bodyPr wrap="square" lIns="45720" rIns="45720" tIns="18288" bIns="18288" anchor="t">
+          <a:bodyPr wrap="none" lIns="45720" rIns="45720" tIns="18288" bIns="18288" anchor="t">
             <a:spAutoFit/>
           </a:bodyPr>
           <a:lstStyle/>
           <a:p>
-            <a:pPr algn="ctr"/>
+            <a:pPr algn="l"/>
             <a:r>
               <a:rPr sz="900" b="0" i="0">
                 <a:solidFill>
@@ -25091,7 +25255,7 @@
         <p:spPr>
           <a:xfrm>
             <a:off x="7178039" y="1517904"/>
-            <a:ext cx="868680" cy="219456"/>
+            <a:ext cx="868680" cy="201168"/>
           </a:xfrm>
           <a:prstGeom prst="rect">
             <a:avLst/>
@@ -25101,12 +25265,12 @@
           </a:solidFill>
         </p:spPr>
         <p:txBody>
-          <a:bodyPr wrap="square" lIns="45720" rIns="45720" tIns="18288" bIns="18288" anchor="t">
+          <a:bodyPr wrap="none" lIns="45720" rIns="45720" tIns="18288" bIns="18288" anchor="t">
             <a:spAutoFit/>
           </a:bodyPr>
           <a:lstStyle/>
           <a:p>
-            <a:pPr algn="ctr"/>
+            <a:pPr algn="l"/>
             <a:r>
               <a:rPr sz="900" b="0" i="0">
                 <a:solidFill>
@@ -25150,7 +25314,7 @@
         <p:spPr>
           <a:xfrm>
             <a:off x="9921239" y="1408176"/>
-            <a:ext cx="411480" cy="219456"/>
+            <a:ext cx="411480" cy="201168"/>
           </a:xfrm>
           <a:prstGeom prst="rect">
             <a:avLst/>
@@ -25160,12 +25324,12 @@
           </a:solidFill>
         </p:spPr>
         <p:txBody>
-          <a:bodyPr wrap="square" lIns="45720" rIns="45720" tIns="18288" bIns="18288" anchor="t">
+          <a:bodyPr wrap="none" lIns="45720" rIns="45720" tIns="18288" bIns="18288" anchor="t">
             <a:spAutoFit/>
           </a:bodyPr>
           <a:lstStyle/>
           <a:p>
-            <a:pPr algn="ctr"/>
+            <a:pPr algn="l"/>
             <a:r>
               <a:rPr sz="900" b="0" i="0">
                 <a:solidFill>
@@ -25209,7 +25373,7 @@
         <p:spPr>
           <a:xfrm>
             <a:off x="9829799" y="1920240"/>
-            <a:ext cx="914400" cy="219456"/>
+            <a:ext cx="914400" cy="201168"/>
           </a:xfrm>
           <a:prstGeom prst="rect">
             <a:avLst/>
@@ -25219,12 +25383,12 @@
           </a:solidFill>
         </p:spPr>
         <p:txBody>
-          <a:bodyPr wrap="square" lIns="45720" rIns="45720" tIns="18288" bIns="18288" anchor="t">
+          <a:bodyPr wrap="none" lIns="45720" rIns="45720" tIns="18288" bIns="18288" anchor="t">
             <a:spAutoFit/>
           </a:bodyPr>
           <a:lstStyle/>
           <a:p>
-            <a:pPr algn="ctr"/>
+            <a:pPr algn="l"/>
             <a:r>
               <a:rPr sz="900" b="0" i="0">
                 <a:solidFill>
@@ -25291,7 +25455,7 @@
         <p:spPr>
           <a:xfrm>
             <a:off x="3314699" y="2980944"/>
-            <a:ext cx="960120" cy="219456"/>
+            <a:ext cx="960120" cy="201168"/>
           </a:xfrm>
           <a:prstGeom prst="rect">
             <a:avLst/>
@@ -25301,12 +25465,12 @@
           </a:solidFill>
         </p:spPr>
         <p:txBody>
-          <a:bodyPr wrap="square" lIns="45720" rIns="45720" tIns="18288" bIns="18288" anchor="t">
+          <a:bodyPr wrap="none" lIns="45720" rIns="45720" tIns="18288" bIns="18288" anchor="t">
             <a:spAutoFit/>
           </a:bodyPr>
           <a:lstStyle/>
           <a:p>
-            <a:pPr algn="ctr"/>
+            <a:pPr algn="l"/>
             <a:r>
               <a:rPr sz="900" b="0" i="0">
                 <a:solidFill>
@@ -25350,7 +25514,7 @@
         <p:spPr>
           <a:xfrm>
             <a:off x="1892808" y="3150108"/>
-            <a:ext cx="685800" cy="219456"/>
+            <a:ext cx="685800" cy="201168"/>
           </a:xfrm>
           <a:prstGeom prst="rect">
             <a:avLst/>
@@ -25360,12 +25524,12 @@
           </a:solidFill>
         </p:spPr>
         <p:txBody>
-          <a:bodyPr wrap="square" lIns="45720" rIns="45720" tIns="18288" bIns="18288" anchor="t">
+          <a:bodyPr wrap="none" lIns="45720" rIns="45720" tIns="18288" bIns="18288" anchor="t">
             <a:spAutoFit/>
           </a:bodyPr>
           <a:lstStyle/>
           <a:p>
-            <a:pPr algn="ctr"/>
+            <a:pPr algn="l"/>
             <a:r>
               <a:rPr sz="900" b="0" i="0">
                 <a:solidFill>
@@ -25410,7 +25574,7 @@
         <p:spPr>
           <a:xfrm>
             <a:off x="1828800" y="4119372"/>
-            <a:ext cx="960120" cy="219456"/>
+            <a:ext cx="960120" cy="201168"/>
           </a:xfrm>
           <a:prstGeom prst="rect">
             <a:avLst/>
@@ -25420,12 +25584,12 @@
           </a:solidFill>
         </p:spPr>
         <p:txBody>
-          <a:bodyPr wrap="square" lIns="45720" rIns="45720" tIns="18288" bIns="18288" anchor="t">
+          <a:bodyPr wrap="none" lIns="45720" rIns="45720" tIns="18288" bIns="18288" anchor="t">
             <a:spAutoFit/>
           </a:bodyPr>
           <a:lstStyle/>
           <a:p>
-            <a:pPr algn="ctr"/>
+            <a:pPr algn="l"/>
             <a:r>
               <a:rPr sz="900" b="0" i="0">
                 <a:solidFill>
@@ -25469,7 +25633,7 @@
         <p:spPr>
           <a:xfrm>
             <a:off x="3314699" y="4133088"/>
-            <a:ext cx="960120" cy="219456"/>
+            <a:ext cx="960120" cy="201168"/>
           </a:xfrm>
           <a:prstGeom prst="rect">
             <a:avLst/>
@@ -25479,12 +25643,12 @@
           </a:solidFill>
         </p:spPr>
         <p:txBody>
-          <a:bodyPr wrap="square" lIns="45720" rIns="45720" tIns="18288" bIns="18288" anchor="t">
+          <a:bodyPr wrap="none" lIns="45720" rIns="45720" tIns="18288" bIns="18288" anchor="t">
             <a:spAutoFit/>
           </a:bodyPr>
           <a:lstStyle/>
           <a:p>
-            <a:pPr algn="ctr"/>
+            <a:pPr algn="l"/>
             <a:r>
               <a:rPr sz="900" b="0" i="0">
                 <a:solidFill>
@@ -25528,7 +25692,7 @@
         <p:spPr>
           <a:xfrm>
             <a:off x="4251959" y="3145536"/>
-            <a:ext cx="1005840" cy="219456"/>
+            <a:ext cx="1005840" cy="201168"/>
           </a:xfrm>
           <a:prstGeom prst="rect">
             <a:avLst/>
@@ -25538,12 +25702,12 @@
           </a:solidFill>
         </p:spPr>
         <p:txBody>
-          <a:bodyPr wrap="square" lIns="45720" rIns="45720" tIns="18288" bIns="18288" anchor="t">
+          <a:bodyPr wrap="none" lIns="45720" rIns="45720" tIns="18288" bIns="18288" anchor="t">
             <a:spAutoFit/>
           </a:bodyPr>
           <a:lstStyle/>
           <a:p>
-            <a:pPr algn="ctr"/>
+            <a:pPr algn="l"/>
             <a:r>
               <a:rPr sz="900" b="0" i="0">
                 <a:solidFill>
@@ -25587,7 +25751,7 @@
         <p:spPr>
           <a:xfrm>
             <a:off x="6149339" y="2944368"/>
-            <a:ext cx="457200" cy="219456"/>
+            <a:ext cx="457200" cy="201168"/>
           </a:xfrm>
           <a:prstGeom prst="rect">
             <a:avLst/>
@@ -25597,12 +25761,12 @@
           </a:solidFill>
         </p:spPr>
         <p:txBody>
-          <a:bodyPr wrap="square" lIns="45720" rIns="45720" tIns="18288" bIns="18288" anchor="t">
+          <a:bodyPr wrap="none" lIns="45720" rIns="45720" tIns="18288" bIns="18288" anchor="t">
             <a:spAutoFit/>
           </a:bodyPr>
           <a:lstStyle/>
           <a:p>
-            <a:pPr algn="ctr"/>
+            <a:pPr algn="l"/>
             <a:r>
               <a:rPr sz="900" b="0" i="0">
                 <a:solidFill>
@@ -25646,7 +25810,7 @@
         <p:spPr>
           <a:xfrm>
             <a:off x="6149339" y="4315968"/>
-            <a:ext cx="868680" cy="219456"/>
+            <a:ext cx="868680" cy="201168"/>
           </a:xfrm>
           <a:prstGeom prst="rect">
             <a:avLst/>
@@ -25656,12 +25820,12 @@
           </a:solidFill>
         </p:spPr>
         <p:txBody>
-          <a:bodyPr wrap="square" lIns="45720" rIns="45720" tIns="18288" bIns="18288" anchor="t">
+          <a:bodyPr wrap="none" lIns="45720" rIns="45720" tIns="18288" bIns="18288" anchor="t">
             <a:spAutoFit/>
           </a:bodyPr>
           <a:lstStyle/>
           <a:p>
-            <a:pPr algn="ctr"/>
+            <a:pPr algn="l"/>
             <a:r>
               <a:rPr sz="900" b="0" i="0">
                 <a:solidFill>
@@ -25705,7 +25869,7 @@
         <p:spPr>
           <a:xfrm>
             <a:off x="2057400" y="5166360"/>
-            <a:ext cx="960120" cy="219456"/>
+            <a:ext cx="960120" cy="201168"/>
           </a:xfrm>
           <a:prstGeom prst="rect">
             <a:avLst/>
@@ -25715,12 +25879,12 @@
           </a:solidFill>
         </p:spPr>
         <p:txBody>
-          <a:bodyPr wrap="square" lIns="45720" rIns="45720" tIns="18288" bIns="18288" anchor="t">
+          <a:bodyPr wrap="none" lIns="45720" rIns="45720" tIns="18288" bIns="18288" anchor="t">
             <a:spAutoFit/>
           </a:bodyPr>
           <a:lstStyle/>
           <a:p>
-            <a:pPr algn="ctr"/>
+            <a:pPr algn="l"/>
             <a:r>
               <a:rPr sz="900" b="0" i="0">
                 <a:solidFill>
@@ -25764,7 +25928,7 @@
         <p:spPr>
           <a:xfrm>
             <a:off x="7132320" y="4105656"/>
-            <a:ext cx="960120" cy="219456"/>
+            <a:ext cx="960120" cy="201168"/>
           </a:xfrm>
           <a:prstGeom prst="rect">
             <a:avLst/>
@@ -25774,12 +25938,12 @@
           </a:solidFill>
         </p:spPr>
         <p:txBody>
-          <a:bodyPr wrap="square" lIns="45720" rIns="45720" tIns="18288" bIns="18288" anchor="t">
+          <a:bodyPr wrap="none" lIns="45720" rIns="45720" tIns="18288" bIns="18288" anchor="t">
             <a:spAutoFit/>
           </a:bodyPr>
           <a:lstStyle/>
           <a:p>
-            <a:pPr algn="ctr"/>
+            <a:pPr algn="l"/>
             <a:r>
               <a:rPr sz="900" b="0" i="0">
                 <a:solidFill>
@@ -25846,7 +26010,7 @@
         <p:spPr>
           <a:xfrm>
             <a:off x="9921239" y="3227832"/>
-            <a:ext cx="731520" cy="219456"/>
+            <a:ext cx="731520" cy="201168"/>
           </a:xfrm>
           <a:prstGeom prst="rect">
             <a:avLst/>
@@ -25856,12 +26020,12 @@
           </a:solidFill>
         </p:spPr>
         <p:txBody>
-          <a:bodyPr wrap="square" lIns="45720" rIns="45720" tIns="18288" bIns="18288" anchor="t">
+          <a:bodyPr wrap="none" lIns="45720" rIns="45720" tIns="18288" bIns="18288" anchor="t">
             <a:spAutoFit/>
           </a:bodyPr>
           <a:lstStyle/>
           <a:p>
-            <a:pPr algn="ctr"/>
+            <a:pPr algn="l"/>
             <a:r>
               <a:rPr sz="900" b="0" i="0">
                 <a:solidFill>
@@ -25905,7 +26069,7 @@
         <p:spPr>
           <a:xfrm>
             <a:off x="10012679" y="3849624"/>
-            <a:ext cx="457200" cy="219456"/>
+            <a:ext cx="457200" cy="201168"/>
           </a:xfrm>
           <a:prstGeom prst="rect">
             <a:avLst/>
@@ -25915,12 +26079,12 @@
           </a:solidFill>
         </p:spPr>
         <p:txBody>
-          <a:bodyPr wrap="square" lIns="45720" rIns="45720" tIns="18288" bIns="18288" anchor="t">
+          <a:bodyPr wrap="none" lIns="45720" rIns="45720" tIns="18288" bIns="18288" anchor="t">
             <a:spAutoFit/>
           </a:bodyPr>
           <a:lstStyle/>
           <a:p>
-            <a:pPr algn="ctr"/>
+            <a:pPr algn="l"/>
             <a:r>
               <a:rPr sz="900" b="0" i="0">
                 <a:solidFill>
@@ -26030,7 +26194,7 @@
         <p:spPr>
           <a:xfrm>
             <a:off x="7132319" y="5980176"/>
-            <a:ext cx="1051560" cy="219456"/>
+            <a:ext cx="1051560" cy="201168"/>
           </a:xfrm>
           <a:prstGeom prst="rect">
             <a:avLst/>
@@ -26040,12 +26204,12 @@
           </a:solidFill>
         </p:spPr>
         <p:txBody>
-          <a:bodyPr wrap="square" lIns="45720" rIns="45720" tIns="18288" bIns="18288" anchor="t">
+          <a:bodyPr wrap="none" lIns="45720" rIns="45720" tIns="18288" bIns="18288" anchor="t">
             <a:spAutoFit/>
           </a:bodyPr>
           <a:lstStyle/>
           <a:p>
-            <a:pPr algn="ctr"/>
+            <a:pPr algn="l"/>
             <a:r>
               <a:rPr sz="900" b="0" i="0">
                 <a:solidFill>

</xml_diff>